<commit_message>
Simplify A44 layout filenames
</commit_message>
<xml_diff>
--- a/docs/slides/A44_SAR_ADC_LAYOUT_REVIEW_20260821.pptx
+++ b/docs/slides/A44_SAR_ADC_LAYOUT_REVIEW_20260821.pptx
@@ -2215,7 +2215,7 @@
       </p:sp>
       <p:pic>
         <p:nvPicPr>
-          <p:cNvPr id="18" name="Image 0" descr="D:\PICO\A44_CHIPATHON_2026_LAYOUT_REVIEW_STAGING_20260815_R1\layout\images\A44_SAR_ADC_CORE_1000_R3_DUMMY_FILL_REPAIR.png">    </p:cNvPr>
+          <p:cNvPr id="18" name="Image 0" descr="D:\PICO\A44_CHIPATHON_2026_LAYOUT_REVIEW_STAGING_20260815_R1\layout\images\A44_SAR_ADC_CORE_1000.png">    </p:cNvPr>
           <p:cNvPicPr>
             <a:picLocks noChangeAspect="1"/>
           </p:cNvPicPr>
@@ -2272,7 +2272,7 @@
                 <a:ea typeface="Aptos" pitchFamily="34" charset="-122"/>
                 <a:cs typeface="Aptos" pitchFamily="34" charset="-120"/>
               </a:rPr>
-              <a:t>A44_SAR_ADC_CORE_1000_R3_DUMMY_FILL_REPAIR</a:t>
+              <a:t>A44_SAR_ADC_CORE_1000</a:t>
             </a:r>
             <a:endParaRPr lang="en-US" sz="900" dirty="0"/>
           </a:p>
@@ -2944,7 +2944,7 @@
                   <a:srgbClr val="DCE8F4"/>
                 </a:solidFill>
               </a:rPr>
-              <a:t>gds/$TOP_LAYOUT.gds</a:t>
+              <a:t>configured LAYOUT_FILE path</a:t>
             </a:r>
             <a:endParaRPr lang="en-US" sz="850" dirty="0"/>
           </a:p>
@@ -3045,7 +3045,7 @@
                   <a:srgbClr val="0B1F33"/>
                 </a:solidFill>
               </a:rPr>
-              <a:t>A44_SAR_ADC_CORE_1000_R3_DUMMY_FILL_REPAIR</a:t>
+              <a:t>A44_SAR_ADC_CORE_1000</a:t>
             </a:r>
             <a:endParaRPr lang="en-US" sz="1800" dirty="0"/>
           </a:p>
@@ -3086,7 +3086,7 @@
                 <a:ea typeface="Courier New" pitchFamily="34" charset="-122"/>
                 <a:cs typeface="Courier New" pitchFamily="34" charset="-120"/>
               </a:rPr>
-              <a:t>gds/A44_SAR_ADC_CORE_1000_R3_DUMMY_FILL_REPAIR.gds</a:t>
+              <a:t>gds/A44_SAR_ADC_CORE_1000.gds</a:t>
             </a:r>
             <a:endParaRPr lang="en-US" sz="1000" dirty="0"/>
           </a:p>
@@ -3696,7 +3696,7 @@
       </p:sp>
       <p:pic>
         <p:nvPicPr>
-          <p:cNvPr id="6" name="Image 0" descr="D:\PICO\A44_CHIPATHON_2026_LAYOUT_REVIEW_STAGING_20260815_R1\layout\images\A44_SAR_ADC_CORE_1000_R3_DUMMY_FILL_REPAIR.png">    </p:cNvPr>
+          <p:cNvPr id="6" name="Image 0" descr="D:\PICO\A44_CHIPATHON_2026_LAYOUT_REVIEW_STAGING_20260815_R1\layout\images\A44_SAR_ADC_CORE_1000.png">    </p:cNvPr>
           <p:cNvPicPr>
             <a:picLocks noChangeAspect="1"/>
           </p:cNvPicPr>
@@ -4848,7 +4848,7 @@
       </p:sp>
       <p:pic>
         <p:nvPicPr>
-          <p:cNvPr id="8" name="Image 0" descr="D:\PICO\A44_CHIPATHON_2026_LAYOUT_REVIEW_STAGING_20260815_R1\layout\images\A44_SAR_ADC_CORE_1000_R3_DUMMY_FILL_REPAIR.png">    </p:cNvPr>
+          <p:cNvPr id="8" name="Image 0" descr="D:\PICO\A44_CHIPATHON_2026_LAYOUT_REVIEW_STAGING_20260815_R1\layout\images\A44_SAR_ADC_CORE_1000.png">    </p:cNvPr>
           <p:cNvPicPr>
             <a:picLocks noChangeAspect="1"/>
           </p:cNvPicPr>
@@ -5031,7 +5031,7 @@
       </p:sp>
       <p:pic>
         <p:nvPicPr>
-          <p:cNvPr id="14" name="Image 1" descr="D:\PICO\A44_CHIPATHON_2026_LAYOUT_REVIEW_STAGING_20260815_R1\layout\images\A44_SAR_ADC_CDAC_E_R7.png">    </p:cNvPr>
+          <p:cNvPr id="14" name="Image 1" descr="D:\PICO\A44_CHIPATHON_2026_LAYOUT_REVIEW_STAGING_20260815_R1\layout\images\A44_SAR_ADC_CDAC_E.png">    </p:cNvPr>
           <p:cNvPicPr>
             <a:picLocks noChangeAspect="1"/>
           </p:cNvPicPr>
@@ -5214,7 +5214,7 @@
       </p:sp>
       <p:pic>
         <p:nvPicPr>
-          <p:cNvPr id="20" name="Image 2" descr="D:\PICO\A44_CHIPATHON_2026_LAYOUT_REVIEW_STAGING_20260815_R1\layout\images\A44_SAR_ADC_CDAC_W_R7.png">    </p:cNvPr>
+          <p:cNvPr id="20" name="Image 2" descr="D:\PICO\A44_CHIPATHON_2026_LAYOUT_REVIEW_STAGING_20260815_R1\layout\images\A44_SAR_ADC_CDAC_W.png">    </p:cNvPr>
           <p:cNvPicPr>
             <a:picLocks noChangeAspect="1"/>
           </p:cNvPicPr>
@@ -5397,7 +5397,7 @@
       </p:sp>
       <p:pic>
         <p:nvPicPr>
-          <p:cNvPr id="26" name="Image 3" descr="D:\PICO\A44_CHIPATHON_2026_LAYOUT_REVIEW_STAGING_20260815_R1\layout\images\A44_SAR_ADC_COMPARATOR_R9.png">    </p:cNvPr>
+          <p:cNvPr id="26" name="Image 3" descr="D:\PICO\A44_CHIPATHON_2026_LAYOUT_REVIEW_STAGING_20260815_R1\layout\images\A44_SAR_ADC_COMPARATOR.png">    </p:cNvPr>
           <p:cNvPicPr>
             <a:picLocks noChangeAspect="1"/>
           </p:cNvPicPr>
@@ -5580,7 +5580,7 @@
       </p:sp>
       <p:pic>
         <p:nvPicPr>
-          <p:cNvPr id="32" name="Image 4" descr="D:\PICO\A44_CHIPATHON_2026_LAYOUT_REVIEW_STAGING_20260815_R1\layout\images\A44_SAR_ADC_SAR_LOGIC_R1L.png">    </p:cNvPr>
+          <p:cNvPr id="32" name="Image 4" descr="D:\PICO\A44_CHIPATHON_2026_LAYOUT_REVIEW_STAGING_20260815_R1\layout\images\A44_SAR_ADC_SAR_LOGIC.png">    </p:cNvPr>
           <p:cNvPicPr>
             <a:picLocks noChangeAspect="1"/>
           </p:cNvPicPr>
@@ -5763,7 +5763,7 @@
       </p:sp>
       <p:pic>
         <p:nvPicPr>
-          <p:cNvPr id="38" name="Image 5" descr="D:\PICO\A44_CHIPATHON_2026_LAYOUT_REVIEW_STAGING_20260815_R1\layout\images\A44_SAR_ADC_CLKS_BUFFER_R1.png">    </p:cNvPr>
+          <p:cNvPr id="38" name="Image 5" descr="D:\PICO\A44_CHIPATHON_2026_LAYOUT_REVIEW_STAGING_20260815_R1\layout\images\A44_SAR_ADC_CLKS_BUFFER.png">    </p:cNvPr>
           <p:cNvPicPr>
             <a:picLocks noChangeAspect="1"/>
           </p:cNvPicPr>
@@ -6140,7 +6140,7 @@
       </p:sp>
       <p:pic>
         <p:nvPicPr>
-          <p:cNvPr id="8" name="Image 0" descr="D:\PICO\A44_CHIPATHON_2026_LAYOUT_REVIEW_STAGING_20260815_R1\layout\images\A44_SAR_ADC_CDAC_E_R7.png">    </p:cNvPr>
+          <p:cNvPr id="8" name="Image 0" descr="D:\PICO\A44_CHIPATHON_2026_LAYOUT_REVIEW_STAGING_20260815_R1\layout\images\A44_SAR_ADC_CDAC_E.png">    </p:cNvPr>
           <p:cNvPicPr>
             <a:picLocks noChangeAspect="1"/>
           </p:cNvPicPr>
@@ -6197,7 +6197,7 @@
                 <a:ea typeface="Aptos Display" pitchFamily="34" charset="-122"/>
                 <a:cs typeface="Aptos Display" pitchFamily="34" charset="-120"/>
               </a:rPr>
-              <a:t>A44_SAR_ADC_CDAC_E_R7</a:t>
+              <a:t>A44_SAR_ADC_CDAC_E</a:t>
             </a:r>
             <a:endParaRPr lang="en-US" sz="1050" dirty="0"/>
           </a:p>
@@ -6323,7 +6323,7 @@
       </p:sp>
       <p:pic>
         <p:nvPicPr>
-          <p:cNvPr id="14" name="Image 1" descr="D:\PICO\A44_CHIPATHON_2026_LAYOUT_REVIEW_STAGING_20260815_R1\layout\images\A44_SAR_ADC_CDAC_W_R7.png">    </p:cNvPr>
+          <p:cNvPr id="14" name="Image 1" descr="D:\PICO\A44_CHIPATHON_2026_LAYOUT_REVIEW_STAGING_20260815_R1\layout\images\A44_SAR_ADC_CDAC_W.png">    </p:cNvPr>
           <p:cNvPicPr>
             <a:picLocks noChangeAspect="1"/>
           </p:cNvPicPr>
@@ -6380,7 +6380,7 @@
                 <a:ea typeface="Aptos Display" pitchFamily="34" charset="-122"/>
                 <a:cs typeface="Aptos Display" pitchFamily="34" charset="-120"/>
               </a:rPr>
-              <a:t>A44_SAR_ADC_CDAC_W_R7</a:t>
+              <a:t>A44_SAR_ADC_CDAC_W</a:t>
             </a:r>
             <a:endParaRPr lang="en-US" sz="1050" dirty="0"/>
           </a:p>
@@ -6774,7 +6774,7 @@
       </p:sp>
       <p:pic>
         <p:nvPicPr>
-          <p:cNvPr id="8" name="Image 0" descr="D:\PICO\A44_CHIPATHON_2026_LAYOUT_REVIEW_STAGING_20260815_R1\layout\images\A44_SAR_ADC_COMPARATOR_R9.png">    </p:cNvPr>
+          <p:cNvPr id="8" name="Image 0" descr="D:\PICO\A44_CHIPATHON_2026_LAYOUT_REVIEW_STAGING_20260815_R1\layout\images\A44_SAR_ADC_COMPARATOR.png">    </p:cNvPr>
           <p:cNvPicPr>
             <a:picLocks noChangeAspect="1"/>
           </p:cNvPicPr>
@@ -6831,7 +6831,7 @@
                 <a:ea typeface="Aptos Display" pitchFamily="34" charset="-122"/>
                 <a:cs typeface="Aptos Display" pitchFamily="34" charset="-120"/>
               </a:rPr>
-              <a:t>Comparator R9</a:t>
+              <a:t>Comparator</a:t>
             </a:r>
             <a:endParaRPr lang="en-US" sz="1050" dirty="0"/>
           </a:p>
@@ -6957,7 +6957,7 @@
       </p:sp>
       <p:pic>
         <p:nvPicPr>
-          <p:cNvPr id="14" name="Image 1" descr="D:\PICO\A44_CHIPATHON_2026_LAYOUT_REVIEW_STAGING_20260815_R1\layout\images\A44_SAR_ADC_SAR_LOGIC_R1L.png">    </p:cNvPr>
+          <p:cNvPr id="14" name="Image 1" descr="D:\PICO\A44_CHIPATHON_2026_LAYOUT_REVIEW_STAGING_20260815_R1\layout\images\A44_SAR_ADC_SAR_LOGIC.png">    </p:cNvPr>
           <p:cNvPicPr>
             <a:picLocks noChangeAspect="1"/>
           </p:cNvPicPr>
@@ -7014,7 +7014,7 @@
                 <a:ea typeface="Aptos Display" pitchFamily="34" charset="-122"/>
                 <a:cs typeface="Aptos Display" pitchFamily="34" charset="-120"/>
               </a:rPr>
-              <a:t>SAR logic R1L</a:t>
+              <a:t>SAR logic</a:t>
             </a:r>
             <a:endParaRPr lang="en-US" sz="1050" dirty="0"/>
           </a:p>
@@ -7140,7 +7140,7 @@
       </p:sp>
       <p:pic>
         <p:nvPicPr>
-          <p:cNvPr id="20" name="Image 2" descr="D:\PICO\A44_CHIPATHON_2026_LAYOUT_REVIEW_STAGING_20260815_R1\layout\images\A44_SAR_ADC_CLKS_BUFFER_R1.png">    </p:cNvPr>
+          <p:cNvPr id="20" name="Image 2" descr="D:\PICO\A44_CHIPATHON_2026_LAYOUT_REVIEW_STAGING_20260815_R1\layout\images\A44_SAR_ADC_CLKS_BUFFER.png">    </p:cNvPr>
           <p:cNvPicPr>
             <a:picLocks noChangeAspect="1"/>
           </p:cNvPicPr>
@@ -7197,7 +7197,7 @@
                 <a:ea typeface="Aptos Display" pitchFamily="34" charset="-122"/>
                 <a:cs typeface="Aptos Display" pitchFamily="34" charset="-120"/>
               </a:rPr>
-              <a:t>Clock buffer R1</a:t>
+              <a:t>Clock buffer</a:t>
             </a:r>
             <a:endParaRPr lang="en-US" sz="1050" dirty="0"/>
           </a:p>

</xml_diff>